<commit_message>
ROI slide: fix line spacing so wrapped lines no longer overlap in PowerPoint
Co-Authored-By: Claude Opus 5.5 <noreply@anthropic.com>
Claude-Session: https://claude.ai/code/session_01RPuitNUVWpBqukB1Jh9qbZ
</commit_message>
<xml_diff>
--- a/deliverables/Claims_denial_navigator_ROI.pptx
+++ b/deliverables/Claims_denial_navigator_ROI.pptx
@@ -26355,7 +26355,7 @@
           <a:p>
             <a:pPr marL="0" indent="0" algn="l">
               <a:lnSpc>
-                <a:spcPct val="95"/>
+                <a:spcPct val="100000"/>
               </a:lnSpc>
               <a:spcBef>
                 <a:spcPts val="0"/>
@@ -26456,7 +26456,7 @@
           <a:p>
             <a:pPr marL="0" indent="0" algn="l">
               <a:lnSpc>
-                <a:spcPct val="95"/>
+                <a:spcPct val="100000"/>
               </a:lnSpc>
               <a:spcBef>
                 <a:spcPts val="0"/>
@@ -26557,7 +26557,7 @@
           <a:p>
             <a:pPr marL="0" indent="0" algn="l">
               <a:lnSpc>
-                <a:spcPct val="95"/>
+                <a:spcPct val="100000"/>
               </a:lnSpc>
               <a:spcBef>
                 <a:spcPts val="0"/>
@@ -26658,7 +26658,7 @@
           <a:p>
             <a:pPr marL="0" indent="0" algn="l">
               <a:lnSpc>
-                <a:spcPct val="95"/>
+                <a:spcPct val="100000"/>
               </a:lnSpc>
               <a:spcBef>
                 <a:spcPts val="0"/>
@@ -26759,7 +26759,7 @@
           <a:p>
             <a:pPr marL="0" indent="0" algn="l">
               <a:lnSpc>
-                <a:spcPct val="95"/>
+                <a:spcPct val="100000"/>
               </a:lnSpc>
               <a:spcBef>
                 <a:spcPts val="0"/>
@@ -26860,7 +26860,7 @@
           <a:p>
             <a:pPr marL="0" indent="0" algn="l">
               <a:lnSpc>
-                <a:spcPct val="95"/>
+                <a:spcPct val="100000"/>
               </a:lnSpc>
               <a:spcBef>
                 <a:spcPts val="0"/>
@@ -26911,7 +26911,7 @@
           <a:p>
             <a:pPr marL="0" indent="0" algn="l">
               <a:lnSpc>
-                <a:spcPct val="105"/>
+                <a:spcPct val="110000"/>
               </a:lnSpc>
               <a:spcBef>
                 <a:spcPts val="0"/>

</xml_diff>